<commit_message>
docs: add Claude free plan screenshots
</commit_message>
<xml_diff>
--- a/lectures/20260723-worklife-ax-workshop/output/worklife-ax-workshop.pptx
+++ b/lectures/20260723-worklife-ax-workshop/output/worklife-ax-workshop.pptx
@@ -24024,52 +24024,35 @@
           </a:p>
         </p:txBody>
       </p:sp>
-      <p:sp>
-        <p:nvSpPr>
-          <p:cNvPr id="5" name="Rectangle 4"/>
-          <p:cNvSpPr/>
-          <p:nvPr/>
-        </p:nvSpPr>
-        <p:spPr>
-          <a:xfrm>
-            <a:off x="548640" y="1600200"/>
-            <a:ext cx="11094415" cy="4160520"/>
+      <p:pic>
+        <p:nvPicPr>
+          <p:cNvPr id="5" name="Picture 4" descr="free_01_signup.png"/>
+          <p:cNvPicPr>
+            <a:picLocks noChangeAspect="1"/>
+          </p:cNvPicPr>
+          <p:nvPr/>
+        </p:nvPicPr>
+        <p:blipFill>
+          <a:blip r:embed="rId2"/>
+          <a:stretch>
+            <a:fillRect/>
+          </a:stretch>
+        </p:blipFill>
+        <p:spPr>
+          <a:xfrm>
+            <a:off x="2767431" y="1600200"/>
+            <a:ext cx="6656832" cy="4160519"/>
           </a:xfrm>
           <a:prstGeom prst="rect">
             <a:avLst/>
           </a:prstGeom>
-          <a:solidFill>
-            <a:srgbClr val="F7F8FA"/>
-          </a:solidFill>
           <a:ln w="9525">
             <a:solidFill>
               <a:srgbClr val="E5E7EB"/>
             </a:solidFill>
           </a:ln>
-          <a:effectLst/>
-        </p:spPr>
-        <p:style>
-          <a:lnRef idx="1">
-            <a:schemeClr val="accent1"/>
-          </a:lnRef>
-          <a:fillRef idx="3">
-            <a:schemeClr val="accent1"/>
-          </a:fillRef>
-          <a:effectRef idx="2">
-            <a:schemeClr val="accent1"/>
-          </a:effectRef>
-          <a:fontRef idx="minor">
-            <a:schemeClr val="lt1"/>
-          </a:fontRef>
-        </p:style>
-        <p:txBody>
-          <a:bodyPr rtlCol="0" anchor="ctr"/>
-          <a:lstStyle/>
-          <a:p>
-            <a:pPr algn="ctr"/>
-          </a:p>
-        </p:txBody>
-      </p:sp>
+        </p:spPr>
+      </p:pic>
       <p:sp>
         <p:nvSpPr>
           <p:cNvPr id="6" name="TextBox 5"/>
@@ -24078,7 +24061,7 @@
         </p:nvSpPr>
         <p:spPr>
           <a:xfrm>
-            <a:off x="548640" y="3154680"/>
+            <a:off x="548640" y="5897880"/>
             <a:ext cx="11094415" cy="457200"/>
           </a:xfrm>
           <a:prstGeom prst="rect">
@@ -24098,13 +24081,13 @@
               </a:lnSpc>
             </a:pPr>
             <a:r>
-              <a:rPr sz="1700" b="1" i="0">
+              <a:rPr sz="1500" b="0" i="0">
                 <a:solidFill>
                   <a:srgbClr val="333333"/>
                 </a:solidFill>
                 <a:latin typeface="Apple SD Gothic Neo"/>
               </a:rPr>
-              <a:t>스크린샷 자리 — assets/screenshots/free_01_signup.png</a:t>
+              <a:t>claude.ai 접속 → 'Google로 계속하기' 또는 이메일 링크 로그인 — 결제 정보는 필요 없습니다</a:t>
             </a:r>
           </a:p>
         </p:txBody>
@@ -24117,8 +24100,8 @@
         </p:nvSpPr>
         <p:spPr>
           <a:xfrm>
-            <a:off x="548640" y="3703320"/>
-            <a:ext cx="11094415" cy="457200"/>
+            <a:off x="548640" y="6492240"/>
+            <a:ext cx="7315200" cy="274320"/>
           </a:xfrm>
           <a:prstGeom prst="rect">
             <a:avLst/>
@@ -24131,7 +24114,7 @@
           </a:bodyPr>
           <a:lstStyle/>
           <a:p>
-            <a:pPr algn="ctr">
+            <a:pPr algn="l">
               <a:lnSpc>
                 <a:spcPct val="115000"/>
               </a:lnSpc>
@@ -24143,7 +24126,7 @@
                 </a:solidFill>
                 <a:latin typeface="Apple SD Gothic Neo"/>
               </a:rPr>
-              <a:t>파일 저장 후 python3 build_pptx/build.py 재실행하면 자동 삽입됩니다</a:t>
+              <a:t>AI 시대의 업무 경쟁력과 생산성 향상 · 2026 청년 여성 밸런스 워크숍</a:t>
             </a:r>
           </a:p>
         </p:txBody>
@@ -24151,84 +24134,6 @@
       <p:sp>
         <p:nvSpPr>
           <p:cNvPr id="8" name="TextBox 7"/>
-          <p:cNvSpPr txBox="1"/>
-          <p:nvPr/>
-        </p:nvSpPr>
-        <p:spPr>
-          <a:xfrm>
-            <a:off x="548640" y="5897880"/>
-            <a:ext cx="11094415" cy="457200"/>
-          </a:xfrm>
-          <a:prstGeom prst="rect">
-            <a:avLst/>
-          </a:prstGeom>
-          <a:noFill/>
-        </p:spPr>
-        <p:txBody>
-          <a:bodyPr wrap="square" lIns="0" rIns="0" tIns="0" bIns="0" anchor="t">
-            <a:spAutoFit/>
-          </a:bodyPr>
-          <a:lstStyle/>
-          <a:p>
-            <a:pPr algn="ctr">
-              <a:lnSpc>
-                <a:spcPct val="115000"/>
-              </a:lnSpc>
-            </a:pPr>
-            <a:r>
-              <a:rPr sz="1500" b="0" i="0">
-                <a:solidFill>
-                  <a:srgbClr val="333333"/>
-                </a:solidFill>
-                <a:latin typeface="Apple SD Gothic Neo"/>
-              </a:rPr>
-              <a:t>claude.ai 접속 → 'Google로 계속하기' 또는 이메일 링크 로그인 — 결제 정보는 필요 없습니다</a:t>
-            </a:r>
-          </a:p>
-        </p:txBody>
-      </p:sp>
-      <p:sp>
-        <p:nvSpPr>
-          <p:cNvPr id="9" name="TextBox 8"/>
-          <p:cNvSpPr txBox="1"/>
-          <p:nvPr/>
-        </p:nvSpPr>
-        <p:spPr>
-          <a:xfrm>
-            <a:off x="548640" y="6492240"/>
-            <a:ext cx="7315200" cy="274320"/>
-          </a:xfrm>
-          <a:prstGeom prst="rect">
-            <a:avLst/>
-          </a:prstGeom>
-          <a:noFill/>
-        </p:spPr>
-        <p:txBody>
-          <a:bodyPr wrap="square" lIns="0" rIns="0" tIns="0" bIns="0" anchor="t">
-            <a:spAutoFit/>
-          </a:bodyPr>
-          <a:lstStyle/>
-          <a:p>
-            <a:pPr algn="l">
-              <a:lnSpc>
-                <a:spcPct val="115000"/>
-              </a:lnSpc>
-            </a:pPr>
-            <a:r>
-              <a:rPr sz="1200" b="0" i="0">
-                <a:solidFill>
-                  <a:srgbClr val="333333"/>
-                </a:solidFill>
-                <a:latin typeface="Apple SD Gothic Neo"/>
-              </a:rPr>
-              <a:t>AI 시대의 업무 경쟁력과 생산성 향상 · 2026 청년 여성 밸런스 워크숍</a:t>
-            </a:r>
-          </a:p>
-        </p:txBody>
-      </p:sp>
-      <p:sp>
-        <p:nvSpPr>
-          <p:cNvPr id="10" name="TextBox 9"/>
           <p:cNvSpPr txBox="1"/>
           <p:nvPr/>
         </p:nvSpPr>
@@ -27102,52 +27007,35 @@
           </a:p>
         </p:txBody>
       </p:sp>
-      <p:sp>
-        <p:nvSpPr>
-          <p:cNvPr id="5" name="Rectangle 4"/>
-          <p:cNvSpPr/>
-          <p:nvPr/>
-        </p:nvSpPr>
-        <p:spPr>
-          <a:xfrm>
-            <a:off x="548640" y="1600200"/>
-            <a:ext cx="11094415" cy="4160520"/>
+      <p:pic>
+        <p:nvPicPr>
+          <p:cNvPr id="5" name="Picture 4" descr="free_06_usage_limit.png"/>
+          <p:cNvPicPr>
+            <a:picLocks noChangeAspect="1"/>
+          </p:cNvPicPr>
+          <p:nvPr/>
+        </p:nvPicPr>
+        <p:blipFill>
+          <a:blip r:embed="rId2"/>
+          <a:stretch>
+            <a:fillRect/>
+          </a:stretch>
+        </p:blipFill>
+        <p:spPr>
+          <a:xfrm>
+            <a:off x="2767431" y="1600200"/>
+            <a:ext cx="6656832" cy="4160519"/>
           </a:xfrm>
           <a:prstGeom prst="rect">
             <a:avLst/>
           </a:prstGeom>
-          <a:solidFill>
-            <a:srgbClr val="F7F8FA"/>
-          </a:solidFill>
           <a:ln w="9525">
             <a:solidFill>
               <a:srgbClr val="E5E7EB"/>
             </a:solidFill>
           </a:ln>
-          <a:effectLst/>
-        </p:spPr>
-        <p:style>
-          <a:lnRef idx="1">
-            <a:schemeClr val="accent1"/>
-          </a:lnRef>
-          <a:fillRef idx="3">
-            <a:schemeClr val="accent1"/>
-          </a:fillRef>
-          <a:effectRef idx="2">
-            <a:schemeClr val="accent1"/>
-          </a:effectRef>
-          <a:fontRef idx="minor">
-            <a:schemeClr val="lt1"/>
-          </a:fontRef>
-        </p:style>
-        <p:txBody>
-          <a:bodyPr rtlCol="0" anchor="ctr"/>
-          <a:lstStyle/>
-          <a:p>
-            <a:pPr algn="ctr"/>
-          </a:p>
-        </p:txBody>
-      </p:sp>
+        </p:spPr>
+      </p:pic>
       <p:sp>
         <p:nvSpPr>
           <p:cNvPr id="6" name="TextBox 5"/>
@@ -27156,7 +27044,7 @@
         </p:nvSpPr>
         <p:spPr>
           <a:xfrm>
-            <a:off x="548640" y="3154680"/>
+            <a:off x="548640" y="5897880"/>
             <a:ext cx="11094415" cy="457200"/>
           </a:xfrm>
           <a:prstGeom prst="rect">
@@ -27176,13 +27064,13 @@
               </a:lnSpc>
             </a:pPr>
             <a:r>
-              <a:rPr sz="1700" b="1" i="0">
+              <a:rPr sz="1500" b="0" i="0">
                 <a:solidFill>
                   <a:srgbClr val="333333"/>
                 </a:solidFill>
                 <a:latin typeface="Apple SD Gothic Neo"/>
               </a:rPr>
-              <a:t>스크린샷 자리 — assets/screenshots/free_06_usage_limit.png</a:t>
+              <a:t>이 메시지가 떠도 당황하지 않기 — 결과 예시 파일로 이어가고, 휴식 후 재시도하면 됩니다</a:t>
             </a:r>
           </a:p>
         </p:txBody>
@@ -27195,8 +27083,8 @@
         </p:nvSpPr>
         <p:spPr>
           <a:xfrm>
-            <a:off x="548640" y="3703320"/>
-            <a:ext cx="11094415" cy="457200"/>
+            <a:off x="548640" y="6492240"/>
+            <a:ext cx="7315200" cy="274320"/>
           </a:xfrm>
           <a:prstGeom prst="rect">
             <a:avLst/>
@@ -27209,7 +27097,7 @@
           </a:bodyPr>
           <a:lstStyle/>
           <a:p>
-            <a:pPr algn="ctr">
+            <a:pPr algn="l">
               <a:lnSpc>
                 <a:spcPct val="115000"/>
               </a:lnSpc>
@@ -27221,7 +27109,7 @@
                 </a:solidFill>
                 <a:latin typeface="Apple SD Gothic Neo"/>
               </a:rPr>
-              <a:t>파일 저장 후 python3 build_pptx/build.py 재실행하면 자동 삽입됩니다</a:t>
+              <a:t>AI 시대의 업무 경쟁력과 생산성 향상 · 2026 청년 여성 밸런스 워크숍</a:t>
             </a:r>
           </a:p>
         </p:txBody>
@@ -27229,84 +27117,6 @@
       <p:sp>
         <p:nvSpPr>
           <p:cNvPr id="8" name="TextBox 7"/>
-          <p:cNvSpPr txBox="1"/>
-          <p:nvPr/>
-        </p:nvSpPr>
-        <p:spPr>
-          <a:xfrm>
-            <a:off x="548640" y="5897880"/>
-            <a:ext cx="11094415" cy="457200"/>
-          </a:xfrm>
-          <a:prstGeom prst="rect">
-            <a:avLst/>
-          </a:prstGeom>
-          <a:noFill/>
-        </p:spPr>
-        <p:txBody>
-          <a:bodyPr wrap="square" lIns="0" rIns="0" tIns="0" bIns="0" anchor="t">
-            <a:spAutoFit/>
-          </a:bodyPr>
-          <a:lstStyle/>
-          <a:p>
-            <a:pPr algn="ctr">
-              <a:lnSpc>
-                <a:spcPct val="115000"/>
-              </a:lnSpc>
-            </a:pPr>
-            <a:r>
-              <a:rPr sz="1500" b="0" i="0">
-                <a:solidFill>
-                  <a:srgbClr val="333333"/>
-                </a:solidFill>
-                <a:latin typeface="Apple SD Gothic Neo"/>
-              </a:rPr>
-              <a:t>이 메시지가 떠도 당황하지 않기 — 결과 예시 파일로 이어가고, 휴식 후 재시도하면 됩니다</a:t>
-            </a:r>
-          </a:p>
-        </p:txBody>
-      </p:sp>
-      <p:sp>
-        <p:nvSpPr>
-          <p:cNvPr id="9" name="TextBox 8"/>
-          <p:cNvSpPr txBox="1"/>
-          <p:nvPr/>
-        </p:nvSpPr>
-        <p:spPr>
-          <a:xfrm>
-            <a:off x="548640" y="6492240"/>
-            <a:ext cx="7315200" cy="274320"/>
-          </a:xfrm>
-          <a:prstGeom prst="rect">
-            <a:avLst/>
-          </a:prstGeom>
-          <a:noFill/>
-        </p:spPr>
-        <p:txBody>
-          <a:bodyPr wrap="square" lIns="0" rIns="0" tIns="0" bIns="0" anchor="t">
-            <a:spAutoFit/>
-          </a:bodyPr>
-          <a:lstStyle/>
-          <a:p>
-            <a:pPr algn="l">
-              <a:lnSpc>
-                <a:spcPct val="115000"/>
-              </a:lnSpc>
-            </a:pPr>
-            <a:r>
-              <a:rPr sz="1200" b="0" i="0">
-                <a:solidFill>
-                  <a:srgbClr val="333333"/>
-                </a:solidFill>
-                <a:latin typeface="Apple SD Gothic Neo"/>
-              </a:rPr>
-              <a:t>AI 시대의 업무 경쟁력과 생산성 향상 · 2026 청년 여성 밸런스 워크숍</a:t>
-            </a:r>
-          </a:p>
-        </p:txBody>
-      </p:sp>
-      <p:sp>
-        <p:nvSpPr>
-          <p:cNvPr id="10" name="TextBox 9"/>
           <p:cNvSpPr txBox="1"/>
           <p:nvPr/>
         </p:nvSpPr>

</xml_diff>